<commit_message>
AG-Folien ergänzt: neue Folie 'Website & Spielwochen-News' + Recap in 'Wo stehen wir?'; PPTX & PDF neu generiert
</commit_message>
<xml_diff>
--- a/M75-Manager-AG-Kurzfassung.pptx
+++ b/M75-Manager-AG-Kurzfassung.pptx
@@ -5,16 +5,17 @@
     <p:sldMasterId id="2147483648" r:id="rId1"/>
   </p:sldMasterIdLst>
   <p:sldIdLst>
-    <p:sldId id="256" r:id="rId2"/>
-    <p:sldId id="257" r:id="rId3"/>
-    <p:sldId id="258" r:id="rId4"/>
-    <p:sldId id="259" r:id="rId5"/>
-    <p:sldId id="260" r:id="rId6"/>
-    <p:sldId id="261" r:id="rId7"/>
-    <p:sldId id="262" r:id="rId8"/>
-    <p:sldId id="263" r:id="rId9"/>
+    <p:sldId id="256" r:id="rId7"/>
+    <p:sldId id="257" r:id="rId8"/>
+    <p:sldId id="258" r:id="rId9"/>
+    <p:sldId id="259" r:id="rId10"/>
+    <p:sldId id="260" r:id="rId11"/>
+    <p:sldId id="261" r:id="rId12"/>
+    <p:sldId id="262" r:id="rId13"/>
+    <p:sldId id="263" r:id="rId14"/>
+    <p:sldId id="264" r:id="rId15"/>
   </p:sldIdLst>
-  <p:sldSz cx="12192000" cy="6858000"/>
+  <p:sldSz cx="12191695" cy="6858000" type="screen4x3"/>
   <p:notesSz cx="6858000" cy="9144000"/>
   <p:defaultTextStyle>
     <a:defPPr>
@@ -111,22 +112,6 @@
       </a:defRPr>
     </a:lvl9pPr>
   </p:defaultTextStyle>
-  <p:extLst>
-    <p:ext uri="{EFAFB233-063F-42B5-8137-9DF3F51BA10A}">
-      <p15:sldGuideLst xmlns:p15="http://schemas.microsoft.com/office/powerpoint/2012/main">
-        <p15:guide id="1" orient="horz" pos="2160">
-          <p15:clr>
-            <a:srgbClr val="A4A3A4"/>
-          </p15:clr>
-        </p15:guide>
-        <p15:guide id="2" pos="2880">
-          <p15:clr>
-            <a:srgbClr val="A4A3A4"/>
-          </p15:clr>
-        </p15:guide>
-      </p15:sldGuideLst>
-    </p:ext>
-  </p:extLst>
 </p:presentation>
 </file>
 
@@ -168,9 +153,10 @@
           <a:lstStyle/>
           <a:p>
             <a:r>
-              <a:rPr lang="en-US"/>
+              <a:rPr lang="en-US" smtClean="0"/>
               <a:t>Click to edit Master title style</a:t>
             </a:r>
+            <a:endParaRPr lang="en-US"/>
           </a:p>
         </p:txBody>
       </p:sp>
@@ -286,9 +272,10 @@
           </a:lstStyle>
           <a:p>
             <a:r>
-              <a:rPr lang="en-US"/>
+              <a:rPr lang="en-US" smtClean="0"/>
               <a:t>Click to edit Master subtitle style</a:t>
             </a:r>
+            <a:endParaRPr lang="en-US"/>
           </a:p>
         </p:txBody>
       </p:sp>
@@ -309,7 +296,7 @@
           <a:p>
             <a:fld id="{5BCAD085-E8A6-8845-BD4E-CB4CCA059FC4}" type="datetimeFigureOut">
               <a:rPr lang="en-US" smtClean="0"/>
-              <a:t>6/29/26</a:t>
+              <a:t>1/27/13</a:t>
             </a:fld>
             <a:endParaRPr lang="en-US"/>
           </a:p>
@@ -351,7 +338,7 @@
           <a:p>
             <a:fld id="{C1FF6DA9-008F-8B48-92A6-B652298478BF}" type="slidenum">
               <a:rPr lang="en-US" smtClean="0"/>
-              <a:t>‹Nr.›</a:t>
+              <a:t>‹#›</a:t>
             </a:fld>
             <a:endParaRPr lang="en-US"/>
           </a:p>
@@ -403,9 +390,10 @@
           <a:lstStyle/>
           <a:p>
             <a:r>
-              <a:rPr lang="en-US"/>
+              <a:rPr lang="en-US" smtClean="0"/>
               <a:t>Click to edit Master title style</a:t>
             </a:r>
+            <a:endParaRPr lang="en-US"/>
           </a:p>
         </p:txBody>
       </p:sp>
@@ -426,37 +414,38 @@
           <a:p>
             <a:pPr lvl="0"/>
             <a:r>
-              <a:rPr lang="en-US"/>
+              <a:rPr lang="en-US" smtClean="0"/>
               <a:t>Click to edit Master text styles</a:t>
             </a:r>
           </a:p>
           <a:p>
             <a:pPr lvl="1"/>
             <a:r>
-              <a:rPr lang="en-US"/>
+              <a:rPr lang="en-US" smtClean="0"/>
               <a:t>Second level</a:t>
             </a:r>
           </a:p>
           <a:p>
             <a:pPr lvl="2"/>
             <a:r>
-              <a:rPr lang="en-US"/>
+              <a:rPr lang="en-US" smtClean="0"/>
               <a:t>Third level</a:t>
             </a:r>
           </a:p>
           <a:p>
             <a:pPr lvl="3"/>
             <a:r>
-              <a:rPr lang="en-US"/>
+              <a:rPr lang="en-US" smtClean="0"/>
               <a:t>Fourth level</a:t>
             </a:r>
           </a:p>
           <a:p>
             <a:pPr lvl="4"/>
             <a:r>
-              <a:rPr lang="en-US"/>
+              <a:rPr lang="en-US" smtClean="0"/>
               <a:t>Fifth level</a:t>
             </a:r>
+            <a:endParaRPr lang="en-US"/>
           </a:p>
         </p:txBody>
       </p:sp>
@@ -477,7 +466,7 @@
           <a:p>
             <a:fld id="{5BCAD085-E8A6-8845-BD4E-CB4CCA059FC4}" type="datetimeFigureOut">
               <a:rPr lang="en-US" smtClean="0"/>
-              <a:t>6/29/26</a:t>
+              <a:t>1/27/13</a:t>
             </a:fld>
             <a:endParaRPr lang="en-US"/>
           </a:p>
@@ -519,7 +508,7 @@
           <a:p>
             <a:fld id="{C1FF6DA9-008F-8B48-92A6-B652298478BF}" type="slidenum">
               <a:rPr lang="en-US" smtClean="0"/>
-              <a:t>‹Nr.›</a:t>
+              <a:t>‹#›</a:t>
             </a:fld>
             <a:endParaRPr lang="en-US"/>
           </a:p>
@@ -576,9 +565,10 @@
           <a:lstStyle/>
           <a:p>
             <a:r>
-              <a:rPr lang="en-US"/>
+              <a:rPr lang="en-US" smtClean="0"/>
               <a:t>Click to edit Master title style</a:t>
             </a:r>
+            <a:endParaRPr lang="en-US"/>
           </a:p>
         </p:txBody>
       </p:sp>
@@ -604,37 +594,38 @@
           <a:p>
             <a:pPr lvl="0"/>
             <a:r>
-              <a:rPr lang="en-US"/>
+              <a:rPr lang="en-US" smtClean="0"/>
               <a:t>Click to edit Master text styles</a:t>
             </a:r>
           </a:p>
           <a:p>
             <a:pPr lvl="1"/>
             <a:r>
-              <a:rPr lang="en-US"/>
+              <a:rPr lang="en-US" smtClean="0"/>
               <a:t>Second level</a:t>
             </a:r>
           </a:p>
           <a:p>
             <a:pPr lvl="2"/>
             <a:r>
-              <a:rPr lang="en-US"/>
+              <a:rPr lang="en-US" smtClean="0"/>
               <a:t>Third level</a:t>
             </a:r>
           </a:p>
           <a:p>
             <a:pPr lvl="3"/>
             <a:r>
-              <a:rPr lang="en-US"/>
+              <a:rPr lang="en-US" smtClean="0"/>
               <a:t>Fourth level</a:t>
             </a:r>
           </a:p>
           <a:p>
             <a:pPr lvl="4"/>
             <a:r>
-              <a:rPr lang="en-US"/>
+              <a:rPr lang="en-US" smtClean="0"/>
               <a:t>Fifth level</a:t>
             </a:r>
+            <a:endParaRPr lang="en-US"/>
           </a:p>
         </p:txBody>
       </p:sp>
@@ -655,7 +646,7 @@
           <a:p>
             <a:fld id="{5BCAD085-E8A6-8845-BD4E-CB4CCA059FC4}" type="datetimeFigureOut">
               <a:rPr lang="en-US" smtClean="0"/>
-              <a:t>6/29/26</a:t>
+              <a:t>1/27/13</a:t>
             </a:fld>
             <a:endParaRPr lang="en-US"/>
           </a:p>
@@ -697,7 +688,7 @@
           <a:p>
             <a:fld id="{C1FF6DA9-008F-8B48-92A6-B652298478BF}" type="slidenum">
               <a:rPr lang="en-US" smtClean="0"/>
-              <a:t>‹Nr.›</a:t>
+              <a:t>‹#›</a:t>
             </a:fld>
             <a:endParaRPr lang="en-US"/>
           </a:p>
@@ -749,9 +740,10 @@
           <a:lstStyle/>
           <a:p>
             <a:r>
-              <a:rPr lang="en-US"/>
+              <a:rPr lang="en-US" smtClean="0"/>
               <a:t>Click to edit Master title style</a:t>
             </a:r>
+            <a:endParaRPr lang="en-US"/>
           </a:p>
         </p:txBody>
       </p:sp>
@@ -772,37 +764,38 @@
           <a:p>
             <a:pPr lvl="0"/>
             <a:r>
-              <a:rPr lang="en-US"/>
+              <a:rPr lang="en-US" smtClean="0"/>
               <a:t>Click to edit Master text styles</a:t>
             </a:r>
           </a:p>
           <a:p>
             <a:pPr lvl="1"/>
             <a:r>
-              <a:rPr lang="en-US"/>
+              <a:rPr lang="en-US" smtClean="0"/>
               <a:t>Second level</a:t>
             </a:r>
           </a:p>
           <a:p>
             <a:pPr lvl="2"/>
             <a:r>
-              <a:rPr lang="en-US"/>
+              <a:rPr lang="en-US" smtClean="0"/>
               <a:t>Third level</a:t>
             </a:r>
           </a:p>
           <a:p>
             <a:pPr lvl="3"/>
             <a:r>
-              <a:rPr lang="en-US"/>
+              <a:rPr lang="en-US" smtClean="0"/>
               <a:t>Fourth level</a:t>
             </a:r>
           </a:p>
           <a:p>
             <a:pPr lvl="4"/>
             <a:r>
-              <a:rPr lang="en-US"/>
+              <a:rPr lang="en-US" smtClean="0"/>
               <a:t>Fifth level</a:t>
             </a:r>
+            <a:endParaRPr lang="en-US"/>
           </a:p>
         </p:txBody>
       </p:sp>
@@ -823,7 +816,7 @@
           <a:p>
             <a:fld id="{5BCAD085-E8A6-8845-BD4E-CB4CCA059FC4}" type="datetimeFigureOut">
               <a:rPr lang="en-US" smtClean="0"/>
-              <a:t>6/29/26</a:t>
+              <a:t>1/27/13</a:t>
             </a:fld>
             <a:endParaRPr lang="en-US"/>
           </a:p>
@@ -865,7 +858,7 @@
           <a:p>
             <a:fld id="{C1FF6DA9-008F-8B48-92A6-B652298478BF}" type="slidenum">
               <a:rPr lang="en-US" smtClean="0"/>
-              <a:t>‹Nr.›</a:t>
+              <a:t>‹#›</a:t>
             </a:fld>
             <a:endParaRPr lang="en-US"/>
           </a:p>
@@ -926,9 +919,10 @@
           </a:lstStyle>
           <a:p>
             <a:r>
-              <a:rPr lang="en-US"/>
+              <a:rPr lang="en-US" smtClean="0"/>
               <a:t>Click to edit Master title style</a:t>
             </a:r>
+            <a:endParaRPr lang="en-US"/>
           </a:p>
         </p:txBody>
       </p:sp>
@@ -1045,7 +1039,7 @@
           <a:p>
             <a:pPr lvl="0"/>
             <a:r>
-              <a:rPr lang="en-US"/>
+              <a:rPr lang="en-US" smtClean="0"/>
               <a:t>Click to edit Master text styles</a:t>
             </a:r>
           </a:p>
@@ -1068,7 +1062,7 @@
           <a:p>
             <a:fld id="{5BCAD085-E8A6-8845-BD4E-CB4CCA059FC4}" type="datetimeFigureOut">
               <a:rPr lang="en-US" smtClean="0"/>
-              <a:t>6/29/26</a:t>
+              <a:t>1/27/13</a:t>
             </a:fld>
             <a:endParaRPr lang="en-US"/>
           </a:p>
@@ -1110,7 +1104,7 @@
           <a:p>
             <a:fld id="{C1FF6DA9-008F-8B48-92A6-B652298478BF}" type="slidenum">
               <a:rPr lang="en-US" smtClean="0"/>
-              <a:t>‹Nr.›</a:t>
+              <a:t>‹#›</a:t>
             </a:fld>
             <a:endParaRPr lang="en-US"/>
           </a:p>
@@ -1162,9 +1156,10 @@
           <a:lstStyle/>
           <a:p>
             <a:r>
-              <a:rPr lang="en-US"/>
+              <a:rPr lang="en-US" smtClean="0"/>
               <a:t>Click to edit Master title style</a:t>
             </a:r>
+            <a:endParaRPr lang="en-US"/>
           </a:p>
         </p:txBody>
       </p:sp>
@@ -1218,37 +1213,38 @@
           <a:p>
             <a:pPr lvl="0"/>
             <a:r>
-              <a:rPr lang="en-US"/>
+              <a:rPr lang="en-US" smtClean="0"/>
               <a:t>Click to edit Master text styles</a:t>
             </a:r>
           </a:p>
           <a:p>
             <a:pPr lvl="1"/>
             <a:r>
-              <a:rPr lang="en-US"/>
+              <a:rPr lang="en-US" smtClean="0"/>
               <a:t>Second level</a:t>
             </a:r>
           </a:p>
           <a:p>
             <a:pPr lvl="2"/>
             <a:r>
-              <a:rPr lang="en-US"/>
+              <a:rPr lang="en-US" smtClean="0"/>
               <a:t>Third level</a:t>
             </a:r>
           </a:p>
           <a:p>
             <a:pPr lvl="3"/>
             <a:r>
-              <a:rPr lang="en-US"/>
+              <a:rPr lang="en-US" smtClean="0"/>
               <a:t>Fourth level</a:t>
             </a:r>
           </a:p>
           <a:p>
             <a:pPr lvl="4"/>
             <a:r>
-              <a:rPr lang="en-US"/>
+              <a:rPr lang="en-US" smtClean="0"/>
               <a:t>Fifth level</a:t>
             </a:r>
+            <a:endParaRPr lang="en-US"/>
           </a:p>
         </p:txBody>
       </p:sp>
@@ -1302,37 +1298,38 @@
           <a:p>
             <a:pPr lvl="0"/>
             <a:r>
-              <a:rPr lang="en-US"/>
+              <a:rPr lang="en-US" smtClean="0"/>
               <a:t>Click to edit Master text styles</a:t>
             </a:r>
           </a:p>
           <a:p>
             <a:pPr lvl="1"/>
             <a:r>
-              <a:rPr lang="en-US"/>
+              <a:rPr lang="en-US" smtClean="0"/>
               <a:t>Second level</a:t>
             </a:r>
           </a:p>
           <a:p>
             <a:pPr lvl="2"/>
             <a:r>
-              <a:rPr lang="en-US"/>
+              <a:rPr lang="en-US" smtClean="0"/>
               <a:t>Third level</a:t>
             </a:r>
           </a:p>
           <a:p>
             <a:pPr lvl="3"/>
             <a:r>
-              <a:rPr lang="en-US"/>
+              <a:rPr lang="en-US" smtClean="0"/>
               <a:t>Fourth level</a:t>
             </a:r>
           </a:p>
           <a:p>
             <a:pPr lvl="4"/>
             <a:r>
-              <a:rPr lang="en-US"/>
+              <a:rPr lang="en-US" smtClean="0"/>
               <a:t>Fifth level</a:t>
             </a:r>
+            <a:endParaRPr lang="en-US"/>
           </a:p>
         </p:txBody>
       </p:sp>
@@ -1353,7 +1350,7 @@
           <a:p>
             <a:fld id="{5BCAD085-E8A6-8845-BD4E-CB4CCA059FC4}" type="datetimeFigureOut">
               <a:rPr lang="en-US" smtClean="0"/>
-              <a:t>6/29/26</a:t>
+              <a:t>1/27/13</a:t>
             </a:fld>
             <a:endParaRPr lang="en-US"/>
           </a:p>
@@ -1395,7 +1392,7 @@
           <a:p>
             <a:fld id="{C1FF6DA9-008F-8B48-92A6-B652298478BF}" type="slidenum">
               <a:rPr lang="en-US" smtClean="0"/>
-              <a:t>‹Nr.›</a:t>
+              <a:t>‹#›</a:t>
             </a:fld>
             <a:endParaRPr lang="en-US"/>
           </a:p>
@@ -1451,9 +1448,10 @@
           </a:lstStyle>
           <a:p>
             <a:r>
-              <a:rPr lang="en-US"/>
+              <a:rPr lang="en-US" smtClean="0"/>
               <a:t>Click to edit Master title style</a:t>
             </a:r>
+            <a:endParaRPr lang="en-US"/>
           </a:p>
         </p:txBody>
       </p:sp>
@@ -1516,7 +1514,7 @@
           <a:p>
             <a:pPr lvl="0"/>
             <a:r>
-              <a:rPr lang="en-US"/>
+              <a:rPr lang="en-US" smtClean="0"/>
               <a:t>Click to edit Master text styles</a:t>
             </a:r>
           </a:p>
@@ -1572,37 +1570,38 @@
           <a:p>
             <a:pPr lvl="0"/>
             <a:r>
-              <a:rPr lang="en-US"/>
+              <a:rPr lang="en-US" smtClean="0"/>
               <a:t>Click to edit Master text styles</a:t>
             </a:r>
           </a:p>
           <a:p>
             <a:pPr lvl="1"/>
             <a:r>
-              <a:rPr lang="en-US"/>
+              <a:rPr lang="en-US" smtClean="0"/>
               <a:t>Second level</a:t>
             </a:r>
           </a:p>
           <a:p>
             <a:pPr lvl="2"/>
             <a:r>
-              <a:rPr lang="en-US"/>
+              <a:rPr lang="en-US" smtClean="0"/>
               <a:t>Third level</a:t>
             </a:r>
           </a:p>
           <a:p>
             <a:pPr lvl="3"/>
             <a:r>
-              <a:rPr lang="en-US"/>
+              <a:rPr lang="en-US" smtClean="0"/>
               <a:t>Fourth level</a:t>
             </a:r>
           </a:p>
           <a:p>
             <a:pPr lvl="4"/>
             <a:r>
-              <a:rPr lang="en-US"/>
+              <a:rPr lang="en-US" smtClean="0"/>
               <a:t>Fifth level</a:t>
             </a:r>
+            <a:endParaRPr lang="en-US"/>
           </a:p>
         </p:txBody>
       </p:sp>
@@ -1665,7 +1664,7 @@
           <a:p>
             <a:pPr lvl="0"/>
             <a:r>
-              <a:rPr lang="en-US"/>
+              <a:rPr lang="en-US" smtClean="0"/>
               <a:t>Click to edit Master text styles</a:t>
             </a:r>
           </a:p>
@@ -1721,37 +1720,38 @@
           <a:p>
             <a:pPr lvl="0"/>
             <a:r>
-              <a:rPr lang="en-US"/>
+              <a:rPr lang="en-US" smtClean="0"/>
               <a:t>Click to edit Master text styles</a:t>
             </a:r>
           </a:p>
           <a:p>
             <a:pPr lvl="1"/>
             <a:r>
-              <a:rPr lang="en-US"/>
+              <a:rPr lang="en-US" smtClean="0"/>
               <a:t>Second level</a:t>
             </a:r>
           </a:p>
           <a:p>
             <a:pPr lvl="2"/>
             <a:r>
-              <a:rPr lang="en-US"/>
+              <a:rPr lang="en-US" smtClean="0"/>
               <a:t>Third level</a:t>
             </a:r>
           </a:p>
           <a:p>
             <a:pPr lvl="3"/>
             <a:r>
-              <a:rPr lang="en-US"/>
+              <a:rPr lang="en-US" smtClean="0"/>
               <a:t>Fourth level</a:t>
             </a:r>
           </a:p>
           <a:p>
             <a:pPr lvl="4"/>
             <a:r>
-              <a:rPr lang="en-US"/>
+              <a:rPr lang="en-US" smtClean="0"/>
               <a:t>Fifth level</a:t>
             </a:r>
+            <a:endParaRPr lang="en-US"/>
           </a:p>
         </p:txBody>
       </p:sp>
@@ -1772,7 +1772,7 @@
           <a:p>
             <a:fld id="{5BCAD085-E8A6-8845-BD4E-CB4CCA059FC4}" type="datetimeFigureOut">
               <a:rPr lang="en-US" smtClean="0"/>
-              <a:t>6/29/26</a:t>
+              <a:t>1/27/13</a:t>
             </a:fld>
             <a:endParaRPr lang="en-US"/>
           </a:p>
@@ -1814,7 +1814,7 @@
           <a:p>
             <a:fld id="{C1FF6DA9-008F-8B48-92A6-B652298478BF}" type="slidenum">
               <a:rPr lang="en-US" smtClean="0"/>
-              <a:t>‹Nr.›</a:t>
+              <a:t>‹#›</a:t>
             </a:fld>
             <a:endParaRPr lang="en-US"/>
           </a:p>
@@ -1866,9 +1866,10 @@
           <a:lstStyle/>
           <a:p>
             <a:r>
-              <a:rPr lang="en-US"/>
+              <a:rPr lang="en-US" smtClean="0"/>
               <a:t>Click to edit Master title style</a:t>
             </a:r>
+            <a:endParaRPr lang="en-US"/>
           </a:p>
         </p:txBody>
       </p:sp>
@@ -1889,7 +1890,7 @@
           <a:p>
             <a:fld id="{5BCAD085-E8A6-8845-BD4E-CB4CCA059FC4}" type="datetimeFigureOut">
               <a:rPr lang="en-US" smtClean="0"/>
-              <a:t>6/29/26</a:t>
+              <a:t>1/27/13</a:t>
             </a:fld>
             <a:endParaRPr lang="en-US"/>
           </a:p>
@@ -1931,7 +1932,7 @@
           <a:p>
             <a:fld id="{C1FF6DA9-008F-8B48-92A6-B652298478BF}" type="slidenum">
               <a:rPr lang="en-US" smtClean="0"/>
-              <a:t>‹Nr.›</a:t>
+              <a:t>‹#›</a:t>
             </a:fld>
             <a:endParaRPr lang="en-US"/>
           </a:p>
@@ -1984,7 +1985,7 @@
           <a:p>
             <a:fld id="{5BCAD085-E8A6-8845-BD4E-CB4CCA059FC4}" type="datetimeFigureOut">
               <a:rPr lang="en-US" smtClean="0"/>
-              <a:t>6/29/26</a:t>
+              <a:t>1/27/13</a:t>
             </a:fld>
             <a:endParaRPr lang="en-US"/>
           </a:p>
@@ -2026,7 +2027,7 @@
           <a:p>
             <a:fld id="{C1FF6DA9-008F-8B48-92A6-B652298478BF}" type="slidenum">
               <a:rPr lang="en-US" smtClean="0"/>
-              <a:t>‹Nr.›</a:t>
+              <a:t>‹#›</a:t>
             </a:fld>
             <a:endParaRPr lang="en-US"/>
           </a:p>
@@ -2087,9 +2088,10 @@
           </a:lstStyle>
           <a:p>
             <a:r>
-              <a:rPr lang="en-US"/>
+              <a:rPr lang="en-US" smtClean="0"/>
               <a:t>Click to edit Master title style</a:t>
             </a:r>
+            <a:endParaRPr lang="en-US"/>
           </a:p>
         </p:txBody>
       </p:sp>
@@ -2143,37 +2145,38 @@
           <a:p>
             <a:pPr lvl="0"/>
             <a:r>
-              <a:rPr lang="en-US"/>
+              <a:rPr lang="en-US" smtClean="0"/>
               <a:t>Click to edit Master text styles</a:t>
             </a:r>
           </a:p>
           <a:p>
             <a:pPr lvl="1"/>
             <a:r>
-              <a:rPr lang="en-US"/>
+              <a:rPr lang="en-US" smtClean="0"/>
               <a:t>Second level</a:t>
             </a:r>
           </a:p>
           <a:p>
             <a:pPr lvl="2"/>
             <a:r>
-              <a:rPr lang="en-US"/>
+              <a:rPr lang="en-US" smtClean="0"/>
               <a:t>Third level</a:t>
             </a:r>
           </a:p>
           <a:p>
             <a:pPr lvl="3"/>
             <a:r>
-              <a:rPr lang="en-US"/>
+              <a:rPr lang="en-US" smtClean="0"/>
               <a:t>Fourth level</a:t>
             </a:r>
           </a:p>
           <a:p>
             <a:pPr lvl="4"/>
             <a:r>
-              <a:rPr lang="en-US"/>
+              <a:rPr lang="en-US" smtClean="0"/>
               <a:t>Fifth level</a:t>
             </a:r>
+            <a:endParaRPr lang="en-US"/>
           </a:p>
         </p:txBody>
       </p:sp>
@@ -2236,7 +2239,7 @@
           <a:p>
             <a:pPr lvl="0"/>
             <a:r>
-              <a:rPr lang="en-US"/>
+              <a:rPr lang="en-US" smtClean="0"/>
               <a:t>Click to edit Master text styles</a:t>
             </a:r>
           </a:p>
@@ -2259,7 +2262,7 @@
           <a:p>
             <a:fld id="{5BCAD085-E8A6-8845-BD4E-CB4CCA059FC4}" type="datetimeFigureOut">
               <a:rPr lang="en-US" smtClean="0"/>
-              <a:t>6/29/26</a:t>
+              <a:t>1/27/13</a:t>
             </a:fld>
             <a:endParaRPr lang="en-US"/>
           </a:p>
@@ -2301,7 +2304,7 @@
           <a:p>
             <a:fld id="{C1FF6DA9-008F-8B48-92A6-B652298478BF}" type="slidenum">
               <a:rPr lang="en-US" smtClean="0"/>
-              <a:t>‹Nr.›</a:t>
+              <a:t>‹#›</a:t>
             </a:fld>
             <a:endParaRPr lang="en-US"/>
           </a:p>
@@ -2362,9 +2365,10 @@
           </a:lstStyle>
           <a:p>
             <a:r>
-              <a:rPr lang="en-US"/>
+              <a:rPr lang="en-US" smtClean="0"/>
               <a:t>Click to edit Master title style</a:t>
             </a:r>
+            <a:endParaRPr lang="en-US"/>
           </a:p>
         </p:txBody>
       </p:sp>
@@ -2488,7 +2492,7 @@
           <a:p>
             <a:pPr lvl="0"/>
             <a:r>
-              <a:rPr lang="en-US"/>
+              <a:rPr lang="en-US" smtClean="0"/>
               <a:t>Click to edit Master text styles</a:t>
             </a:r>
           </a:p>
@@ -2511,7 +2515,7 @@
           <a:p>
             <a:fld id="{5BCAD085-E8A6-8845-BD4E-CB4CCA059FC4}" type="datetimeFigureOut">
               <a:rPr lang="en-US" smtClean="0"/>
-              <a:t>6/29/26</a:t>
+              <a:t>1/27/13</a:t>
             </a:fld>
             <a:endParaRPr lang="en-US"/>
           </a:p>
@@ -2553,7 +2557,7 @@
           <a:p>
             <a:fld id="{C1FF6DA9-008F-8B48-92A6-B652298478BF}" type="slidenum">
               <a:rPr lang="en-US" smtClean="0"/>
-              <a:t>‹Nr.›</a:t>
+              <a:t>‹#›</a:t>
             </a:fld>
             <a:endParaRPr lang="en-US"/>
           </a:p>
@@ -2620,9 +2624,10 @@
           <a:lstStyle/>
           <a:p>
             <a:r>
-              <a:rPr lang="en-US"/>
+              <a:rPr lang="en-US" smtClean="0"/>
               <a:t>Click to edit Master title style</a:t>
             </a:r>
+            <a:endParaRPr lang="en-US"/>
           </a:p>
         </p:txBody>
       </p:sp>
@@ -2653,37 +2658,38 @@
           <a:p>
             <a:pPr lvl="0"/>
             <a:r>
-              <a:rPr lang="en-US"/>
+              <a:rPr lang="en-US" smtClean="0"/>
               <a:t>Click to edit Master text styles</a:t>
             </a:r>
           </a:p>
           <a:p>
             <a:pPr lvl="1"/>
             <a:r>
-              <a:rPr lang="en-US"/>
+              <a:rPr lang="en-US" smtClean="0"/>
               <a:t>Second level</a:t>
             </a:r>
           </a:p>
           <a:p>
             <a:pPr lvl="2"/>
             <a:r>
-              <a:rPr lang="en-US"/>
+              <a:rPr lang="en-US" smtClean="0"/>
               <a:t>Third level</a:t>
             </a:r>
           </a:p>
           <a:p>
             <a:pPr lvl="3"/>
             <a:r>
-              <a:rPr lang="en-US"/>
+              <a:rPr lang="en-US" smtClean="0"/>
               <a:t>Fourth level</a:t>
             </a:r>
           </a:p>
           <a:p>
             <a:pPr lvl="4"/>
             <a:r>
-              <a:rPr lang="en-US"/>
+              <a:rPr lang="en-US" smtClean="0"/>
               <a:t>Fifth level</a:t>
             </a:r>
+            <a:endParaRPr lang="en-US"/>
           </a:p>
         </p:txBody>
       </p:sp>
@@ -2722,7 +2728,7 @@
           <a:p>
             <a:fld id="{5BCAD085-E8A6-8845-BD4E-CB4CCA059FC4}" type="datetimeFigureOut">
               <a:rPr lang="en-US" smtClean="0"/>
-              <a:t>6/29/26</a:t>
+              <a:t>1/27/13</a:t>
             </a:fld>
             <a:endParaRPr lang="en-US"/>
           </a:p>
@@ -2800,7 +2806,7 @@
           <a:p>
             <a:fld id="{C1FF6DA9-008F-8B48-92A6-B652298478BF}" type="slidenum">
               <a:rPr lang="en-US" smtClean="0"/>
-              <a:t>‹Nr.›</a:t>
+              <a:t>‹#›</a:t>
             </a:fld>
             <a:endParaRPr lang="en-US"/>
           </a:p>
@@ -3081,7 +3087,7 @@
 </file>
 
 <file path=ppt/slides/slide1.xml><?xml version="1.0" encoding="utf-8"?>
-<p:sld xmlns:a="http://schemas.openxmlformats.org/drawingml/2006/main" xmlns:r="http://schemas.openxmlformats.org/officeDocument/2006/relationships" xmlns:p="http://schemas.openxmlformats.org/presentationml/2006/main">
+<p:sld xmlns:a="http://schemas.openxmlformats.org/drawingml/2006/main" xmlns:p="http://schemas.openxmlformats.org/presentationml/2006/main" xmlns:r="http://schemas.openxmlformats.org/officeDocument/2006/relationships">
   <p:cSld>
     <p:bg>
       <p:bgPr>
@@ -3097,14 +3103,7 @@
         <p:cNvGrpSpPr/>
         <p:nvPr/>
       </p:nvGrpSpPr>
-      <p:grpSpPr>
-        <a:xfrm>
-          <a:off x="0" y="0"/>
-          <a:ext cx="0" cy="0"/>
-          <a:chOff x="0" y="0"/>
-          <a:chExt cx="0" cy="0"/>
-        </a:xfrm>
-      </p:grpSpPr>
+      <p:grpSpPr/>
       <p:sp>
         <p:nvSpPr>
           <p:cNvPr id="2" name="Rectangle 1"/>
@@ -3145,7 +3144,6 @@
           <a:lstStyle/>
           <a:p>
             <a:pPr algn="ctr"/>
-            <a:endParaRPr/>
           </a:p>
         </p:txBody>
       </p:sp>
@@ -3260,7 +3258,7 @@
 </file>
 
 <file path=ppt/slides/slide2.xml><?xml version="1.0" encoding="utf-8"?>
-<p:sld xmlns:a="http://schemas.openxmlformats.org/drawingml/2006/main" xmlns:r="http://schemas.openxmlformats.org/officeDocument/2006/relationships" xmlns:p="http://schemas.openxmlformats.org/presentationml/2006/main">
+<p:sld xmlns:a="http://schemas.openxmlformats.org/drawingml/2006/main" xmlns:p="http://schemas.openxmlformats.org/presentationml/2006/main" xmlns:r="http://schemas.openxmlformats.org/officeDocument/2006/relationships">
   <p:cSld>
     <p:bg>
       <p:bgPr>
@@ -3276,14 +3274,7 @@
         <p:cNvGrpSpPr/>
         <p:nvPr/>
       </p:nvGrpSpPr>
-      <p:grpSpPr>
-        <a:xfrm>
-          <a:off x="0" y="0"/>
-          <a:ext cx="0" cy="0"/>
-          <a:chOff x="0" y="0"/>
-          <a:chExt cx="0" cy="0"/>
-        </a:xfrm>
-      </p:grpSpPr>
+      <p:grpSpPr/>
       <p:sp>
         <p:nvSpPr>
           <p:cNvPr id="2" name="Rectangle 1"/>
@@ -3324,7 +3315,6 @@
           <a:lstStyle/>
           <a:p>
             <a:pPr algn="ctr"/>
-            <a:endParaRPr/>
           </a:p>
         </p:txBody>
       </p:sp>
@@ -3508,7 +3498,7 @@
 </file>
 
 <file path=ppt/slides/slide3.xml><?xml version="1.0" encoding="utf-8"?>
-<p:sld xmlns:a="http://schemas.openxmlformats.org/drawingml/2006/main" xmlns:r="http://schemas.openxmlformats.org/officeDocument/2006/relationships" xmlns:p="http://schemas.openxmlformats.org/presentationml/2006/main">
+<p:sld xmlns:a="http://schemas.openxmlformats.org/drawingml/2006/main" xmlns:p="http://schemas.openxmlformats.org/presentationml/2006/main" xmlns:r="http://schemas.openxmlformats.org/officeDocument/2006/relationships">
   <p:cSld>
     <p:bg>
       <p:bgPr>
@@ -3524,14 +3514,7 @@
         <p:cNvGrpSpPr/>
         <p:nvPr/>
       </p:nvGrpSpPr>
-      <p:grpSpPr>
-        <a:xfrm>
-          <a:off x="0" y="0"/>
-          <a:ext cx="0" cy="0"/>
-          <a:chOff x="0" y="0"/>
-          <a:chExt cx="0" cy="0"/>
-        </a:xfrm>
-      </p:grpSpPr>
+      <p:grpSpPr/>
       <p:sp>
         <p:nvSpPr>
           <p:cNvPr id="2" name="Rectangle 1"/>
@@ -3572,7 +3555,6 @@
           <a:lstStyle/>
           <a:p>
             <a:pPr algn="ctr"/>
-            <a:endParaRPr/>
           </a:p>
         </p:txBody>
       </p:sp>
@@ -3740,7 +3722,7 @@
 </file>
 
 <file path=ppt/slides/slide4.xml><?xml version="1.0" encoding="utf-8"?>
-<p:sld xmlns:a="http://schemas.openxmlformats.org/drawingml/2006/main" xmlns:r="http://schemas.openxmlformats.org/officeDocument/2006/relationships" xmlns:p="http://schemas.openxmlformats.org/presentationml/2006/main">
+<p:sld xmlns:a="http://schemas.openxmlformats.org/drawingml/2006/main" xmlns:p="http://schemas.openxmlformats.org/presentationml/2006/main" xmlns:r="http://schemas.openxmlformats.org/officeDocument/2006/relationships">
   <p:cSld>
     <p:bg>
       <p:bgPr>
@@ -3756,14 +3738,7 @@
         <p:cNvGrpSpPr/>
         <p:nvPr/>
       </p:nvGrpSpPr>
-      <p:grpSpPr>
-        <a:xfrm>
-          <a:off x="0" y="0"/>
-          <a:ext cx="0" cy="0"/>
-          <a:chOff x="0" y="0"/>
-          <a:chExt cx="0" cy="0"/>
-        </a:xfrm>
-      </p:grpSpPr>
+      <p:grpSpPr/>
       <p:sp>
         <p:nvSpPr>
           <p:cNvPr id="2" name="Rectangle 1"/>
@@ -3804,7 +3779,6 @@
           <a:lstStyle/>
           <a:p>
             <a:pPr algn="ctr"/>
-            <a:endParaRPr/>
           </a:p>
         </p:txBody>
       </p:sp>
@@ -3991,6 +3965,22 @@
                 <a:latin typeface="Calibri"/>
               </a:rPr>
               <a:t>–  KI-Hilfe, Monitoring, automatisches Backup, Messenger (Matrix).</a:t>
+            </a:r>
+          </a:p>
+          <a:p>
+            <a:pPr lvl="1">
+              <a:spcAft>
+                <a:spcPts val="1000"/>
+              </a:spcAft>
+            </a:pPr>
+            <a:r>
+              <a:rPr sz="1700" b="0">
+                <a:solidFill>
+                  <a:srgbClr val="5B6675"/>
+                </a:solidFill>
+                <a:latin typeface="Calibri"/>
+              </a:rPr>
+              <a:t>–  Spielwochen-Recap: wöchentlicher News-Text über alle Spiele (ab 2026/2027).</a:t>
             </a:r>
           </a:p>
           <a:p>
@@ -4020,7 +4010,7 @@
 </file>
 
 <file path=ppt/slides/slide5.xml><?xml version="1.0" encoding="utf-8"?>
-<p:sld xmlns:a="http://schemas.openxmlformats.org/drawingml/2006/main" xmlns:r="http://schemas.openxmlformats.org/officeDocument/2006/relationships" xmlns:p="http://schemas.openxmlformats.org/presentationml/2006/main">
+<p:sld xmlns:a="http://schemas.openxmlformats.org/drawingml/2006/main" xmlns:p="http://schemas.openxmlformats.org/presentationml/2006/main" xmlns:r="http://schemas.openxmlformats.org/officeDocument/2006/relationships">
   <p:cSld>
     <p:bg>
       <p:bgPr>
@@ -4036,14 +4026,7 @@
         <p:cNvGrpSpPr/>
         <p:nvPr/>
       </p:nvGrpSpPr>
-      <p:grpSpPr>
-        <a:xfrm>
-          <a:off x="0" y="0"/>
-          <a:ext cx="0" cy="0"/>
-          <a:chOff x="0" y="0"/>
-          <a:chExt cx="0" cy="0"/>
-        </a:xfrm>
-      </p:grpSpPr>
+      <p:grpSpPr/>
       <p:sp>
         <p:nvSpPr>
           <p:cNvPr id="2" name="Rectangle 1"/>
@@ -4084,7 +4067,6 @@
           <a:lstStyle/>
           <a:p>
             <a:pPr algn="ctr"/>
-            <a:endParaRPr/>
           </a:p>
         </p:txBody>
       </p:sp>
@@ -4151,7 +4133,7 @@
                 </a:solidFill>
                 <a:latin typeface="Calibri"/>
               </a:rPr>
-              <a:t>Größenordnung &amp; Kosten</a:t>
+              <a:t>Neu: Website &amp; Spielwochen-News</a:t>
             </a:r>
           </a:p>
         </p:txBody>
@@ -4190,7 +4172,39 @@
                 </a:solidFill>
                 <a:latin typeface="Calibri"/>
               </a:rPr>
-              <a:t>•  Großes System: ~16.700 Code-Zeilen, 80 Datenbereiche, 233 Funktionen.</a:t>
+              <a:t>•  Erledigt: Sponsoren-/Partner-Seite ist live.</a:t>
+            </a:r>
+          </a:p>
+          <a:p>
+            <a:pPr lvl="1">
+              <a:spcAft>
+                <a:spcPts val="1000"/>
+              </a:spcAft>
+            </a:pPr>
+            <a:r>
+              <a:rPr sz="1700" b="0">
+                <a:solidFill>
+                  <a:srgbClr val="5B6675"/>
+                </a:solidFill>
+                <a:latin typeface="Calibri"/>
+              </a:rPr>
+              <a:t>–  Saison 25/26 sauber archiviert; Spielplan startet leer in 2026/2027.</a:t>
+            </a:r>
+          </a:p>
+          <a:p>
+            <a:pPr lvl="1">
+              <a:spcAft>
+                <a:spcPts val="1000"/>
+              </a:spcAft>
+            </a:pPr>
+            <a:r>
+              <a:rPr sz="1700" b="0">
+                <a:solidFill>
+                  <a:srgbClr val="5B6675"/>
+                </a:solidFill>
+                <a:latin typeface="Calibri"/>
+              </a:rPr>
+              <a:t>–  Der neue Kalender füllt sich automatisch aus den Verbandsdaten.</a:t>
             </a:r>
           </a:p>
           <a:p>
@@ -4206,7 +4220,7 @@
                 </a:solidFill>
                 <a:latin typeface="Calibri"/>
               </a:rPr>
-              <a:t>•  Hosting ca. 60–250 € / Jahr · Software-Lizenzen 0 € (Open Source).</a:t>
+              <a:t>•  Geplant – Spielwochen-Recap auf der News-Seite:</a:t>
             </a:r>
           </a:p>
           <a:p>
@@ -4222,23 +4236,39 @@
                 </a:solidFill>
                 <a:latin typeface="Calibri"/>
               </a:rPr>
-              <a:t>–  Vergleich: kommerzielle Vereins-Software oft mehrere hundert €/Jahr.</a:t>
-            </a:r>
-          </a:p>
-          <a:p>
-            <a:pPr>
+              <a:t>–  Wöchentlich ein kurzer Text über alle Spiele unserer Mannschaften.</a:t>
+            </a:r>
+          </a:p>
+          <a:p>
+            <a:pPr lvl="1">
               <a:spcAft>
                 <a:spcPts val="1000"/>
               </a:spcAft>
             </a:pPr>
             <a:r>
-              <a:rPr sz="2000" b="1">
-                <a:solidFill>
-                  <a:srgbClr val="1C2530"/>
+              <a:rPr sz="1700" b="0">
+                <a:solidFill>
+                  <a:srgbClr val="5B6675"/>
                 </a:solidFill>
                 <a:latin typeface="Calibri"/>
               </a:rPr>
-              <a:t>•  Hauptaufwand ist ehrenamtliche Zeit, nicht Geld.</a:t>
+              <a:t>–  Mehrsprachig; KI macht den Entwurf aus den Ergebnissen, Mensch gibt frei.</a:t>
+            </a:r>
+          </a:p>
+          <a:p>
+            <a:pPr lvl="1">
+              <a:spcAft>
+                <a:spcPts val="1000"/>
+              </a:spcAft>
+            </a:pPr>
+            <a:r>
+              <a:rPr sz="1700" b="0">
+                <a:solidFill>
+                  <a:srgbClr val="5B6675"/>
+                </a:solidFill>
+                <a:latin typeface="Calibri"/>
+              </a:rPr>
+              <a:t>–  Ab Saison 2026/2027, laufend.</a:t>
             </a:r>
           </a:p>
         </p:txBody>
@@ -4252,7 +4282,7 @@
 </file>
 
 <file path=ppt/slides/slide6.xml><?xml version="1.0" encoding="utf-8"?>
-<p:sld xmlns:a="http://schemas.openxmlformats.org/drawingml/2006/main" xmlns:r="http://schemas.openxmlformats.org/officeDocument/2006/relationships" xmlns:p="http://schemas.openxmlformats.org/presentationml/2006/main">
+<p:sld xmlns:a="http://schemas.openxmlformats.org/drawingml/2006/main" xmlns:p="http://schemas.openxmlformats.org/presentationml/2006/main" xmlns:r="http://schemas.openxmlformats.org/officeDocument/2006/relationships">
   <p:cSld>
     <p:bg>
       <p:bgPr>
@@ -4268,14 +4298,7 @@
         <p:cNvGrpSpPr/>
         <p:nvPr/>
       </p:nvGrpSpPr>
-      <p:grpSpPr>
-        <a:xfrm>
-          <a:off x="0" y="0"/>
-          <a:ext cx="0" cy="0"/>
-          <a:chOff x="0" y="0"/>
-          <a:chExt cx="0" cy="0"/>
-        </a:xfrm>
-      </p:grpSpPr>
+      <p:grpSpPr/>
       <p:sp>
         <p:nvSpPr>
           <p:cNvPr id="2" name="Rectangle 1"/>
@@ -4316,7 +4339,6 @@
           <a:lstStyle/>
           <a:p>
             <a:pPr algn="ctr"/>
-            <a:endParaRPr/>
           </a:p>
         </p:txBody>
       </p:sp>
@@ -4383,7 +4405,7 @@
                 </a:solidFill>
                 <a:latin typeface="Calibri"/>
               </a:rPr>
-              <a:t>Risiken – und wie wir sie beherrschen</a:t>
+              <a:t>Größenordnung &amp; Kosten</a:t>
             </a:r>
           </a:p>
         </p:txBody>
@@ -4422,7 +4444,7 @@
                 </a:solidFill>
                 <a:latin typeface="Calibri"/>
               </a:rPr>
-              <a:t>•  Abhängigkeit von einer Person → 2. Person einarbeiten.</a:t>
+              <a:t>•  Großes System: ~16.700 Code-Zeilen, 80 Datenbereiche, 233 Funktionen.</a:t>
             </a:r>
           </a:p>
           <a:p>
@@ -4438,7 +4460,23 @@
                 </a:solidFill>
                 <a:latin typeface="Calibri"/>
               </a:rPr>
-              <a:t>•  Sicherheit (Demo-Passwörter) → vor Echtbetrieb bereinigen.</a:t>
+              <a:t>•  Hosting ca. 60–250 € / Jahr · Software-Lizenzen 0 € (Open Source).</a:t>
+            </a:r>
+          </a:p>
+          <a:p>
+            <a:pPr lvl="1">
+              <a:spcAft>
+                <a:spcPts val="1000"/>
+              </a:spcAft>
+            </a:pPr>
+            <a:r>
+              <a:rPr sz="1700" b="0">
+                <a:solidFill>
+                  <a:srgbClr val="5B6675"/>
+                </a:solidFill>
+                <a:latin typeface="Calibri"/>
+              </a:rPr>
+              <a:t>–  Vergleich: kommerzielle Vereins-Software oft mehrere hundert €/Jahr.</a:t>
             </a:r>
           </a:p>
           <a:p>
@@ -4454,23 +4492,7 @@
                 </a:solidFill>
                 <a:latin typeface="Calibri"/>
               </a:rPr>
-              <a:t>•  Noch kein Auto-Backup → Backup-Konzept zuerst umsetzen.</a:t>
-            </a:r>
-          </a:p>
-          <a:p>
-            <a:pPr>
-              <a:spcAft>
-                <a:spcPts val="1000"/>
-              </a:spcAft>
-            </a:pPr>
-            <a:r>
-              <a:rPr sz="2000" b="1">
-                <a:solidFill>
-                  <a:srgbClr val="1C2530"/>
-                </a:solidFill>
-                <a:latin typeface="Calibri"/>
-              </a:rPr>
-              <a:t>•  Manche Module noch leer -&gt; klar als 'in Entwicklung' kennzeichnen.</a:t>
+              <a:t>•  Hauptaufwand ist ehrenamtliche Zeit, nicht Geld.</a:t>
             </a:r>
           </a:p>
         </p:txBody>
@@ -4484,7 +4506,7 @@
 </file>
 
 <file path=ppt/slides/slide7.xml><?xml version="1.0" encoding="utf-8"?>
-<p:sld xmlns:a="http://schemas.openxmlformats.org/drawingml/2006/main" xmlns:r="http://schemas.openxmlformats.org/officeDocument/2006/relationships" xmlns:p="http://schemas.openxmlformats.org/presentationml/2006/main">
+<p:sld xmlns:a="http://schemas.openxmlformats.org/drawingml/2006/main" xmlns:p="http://schemas.openxmlformats.org/presentationml/2006/main" xmlns:r="http://schemas.openxmlformats.org/officeDocument/2006/relationships">
   <p:cSld>
     <p:bg>
       <p:bgPr>
@@ -4500,14 +4522,7 @@
         <p:cNvGrpSpPr/>
         <p:nvPr/>
       </p:nvGrpSpPr>
-      <p:grpSpPr>
-        <a:xfrm>
-          <a:off x="0" y="0"/>
-          <a:ext cx="0" cy="0"/>
-          <a:chOff x="0" y="0"/>
-          <a:chExt cx="0" cy="0"/>
-        </a:xfrm>
-      </p:grpSpPr>
+      <p:grpSpPr/>
       <p:sp>
         <p:nvSpPr>
           <p:cNvPr id="2" name="Rectangle 1"/>
@@ -4548,7 +4563,6 @@
           <a:lstStyle/>
           <a:p>
             <a:pPr algn="ctr"/>
-            <a:endParaRPr/>
           </a:p>
         </p:txBody>
       </p:sp>
@@ -4615,7 +4629,7 @@
                 </a:solidFill>
                 <a:latin typeface="Calibri"/>
               </a:rPr>
-              <a:t>Antrag an die Versammlung</a:t>
+              <a:t>Risiken – und wie wir sie beherrschen</a:t>
             </a:r>
           </a:p>
         </p:txBody>
@@ -4654,7 +4668,7 @@
                 </a:solidFill>
                 <a:latin typeface="Calibri"/>
               </a:rPr>
-              <a:t>•  Grundsatz: Verein setzt auf das eigene Vereins-OS.</a:t>
+              <a:t>•  Abhängigkeit von einer Person → 2. Person einarbeiten.</a:t>
             </a:r>
           </a:p>
           <a:p>
@@ -4670,7 +4684,7 @@
                 </a:solidFill>
                 <a:latin typeface="Calibri"/>
               </a:rPr>
-              <a:t>•  Budgetfreigabe für Server-Hosting (kleiner Jahresbetrag).</a:t>
+              <a:t>•  Sicherheit (Demo-Passwörter) → vor Echtbetrieb bereinigen.</a:t>
             </a:r>
           </a:p>
           <a:p>
@@ -4686,7 +4700,7 @@
                 </a:solidFill>
                 <a:latin typeface="Calibri"/>
               </a:rPr>
-              <a:t>•  Start Pilotbetrieb: „Mitglieder &amp; Beiträge".</a:t>
+              <a:t>•  Noch kein Auto-Backup → Backup-Konzept zuerst umsetzen.</a:t>
             </a:r>
           </a:p>
           <a:p>
@@ -4702,7 +4716,7 @@
                 </a:solidFill>
                 <a:latin typeface="Calibri"/>
               </a:rPr>
-              <a:t>•  Zweite Person zur Einarbeitung benennen (Ausfallsicherheit).</a:t>
+              <a:t>•  Manche Module noch leer -&gt; klar als 'in Entwicklung' kennzeichnen.</a:t>
             </a:r>
           </a:p>
         </p:txBody>
@@ -4716,7 +4730,231 @@
 </file>
 
 <file path=ppt/slides/slide8.xml><?xml version="1.0" encoding="utf-8"?>
-<p:sld xmlns:a="http://schemas.openxmlformats.org/drawingml/2006/main" xmlns:r="http://schemas.openxmlformats.org/officeDocument/2006/relationships" xmlns:p="http://schemas.openxmlformats.org/presentationml/2006/main">
+<p:sld xmlns:a="http://schemas.openxmlformats.org/drawingml/2006/main" xmlns:p="http://schemas.openxmlformats.org/presentationml/2006/main" xmlns:r="http://schemas.openxmlformats.org/officeDocument/2006/relationships">
+  <p:cSld>
+    <p:bg>
+      <p:bgPr>
+        <a:solidFill>
+          <a:srgbClr val="FFFFFF"/>
+        </a:solidFill>
+        <a:effectLst/>
+      </p:bgPr>
+    </p:bg>
+    <p:spTree>
+      <p:nvGrpSpPr>
+        <p:cNvPr id="1" name=""/>
+        <p:cNvGrpSpPr/>
+        <p:nvPr/>
+      </p:nvGrpSpPr>
+      <p:grpSpPr/>
+      <p:sp>
+        <p:nvSpPr>
+          <p:cNvPr id="2" name="Rectangle 1"/>
+          <p:cNvSpPr/>
+          <p:nvPr/>
+        </p:nvSpPr>
+        <p:spPr>
+          <a:xfrm>
+            <a:off x="0" y="0"/>
+            <a:ext cx="12191695" cy="164592"/>
+          </a:xfrm>
+          <a:prstGeom prst="rect">
+            <a:avLst/>
+          </a:prstGeom>
+          <a:solidFill>
+            <a:srgbClr val="FFDE00"/>
+          </a:solidFill>
+          <a:ln>
+            <a:noFill/>
+          </a:ln>
+        </p:spPr>
+        <p:style>
+          <a:lnRef idx="1">
+            <a:schemeClr val="accent1"/>
+          </a:lnRef>
+          <a:fillRef idx="3">
+            <a:schemeClr val="accent1"/>
+          </a:fillRef>
+          <a:effectRef idx="2">
+            <a:schemeClr val="accent1"/>
+          </a:effectRef>
+          <a:fontRef idx="minor">
+            <a:schemeClr val="lt1"/>
+          </a:fontRef>
+        </p:style>
+        <p:txBody>
+          <a:bodyPr rtlCol="0" anchor="ctr"/>
+          <a:lstStyle/>
+          <a:p>
+            <a:pPr algn="ctr"/>
+          </a:p>
+        </p:txBody>
+      </p:sp>
+      <p:sp>
+        <p:nvSpPr>
+          <p:cNvPr id="3" name="TextBox 2"/>
+          <p:cNvSpPr txBox="1"/>
+          <p:nvPr/>
+        </p:nvSpPr>
+        <p:spPr>
+          <a:xfrm>
+            <a:off x="640080" y="411480"/>
+            <a:ext cx="10972800" cy="365760"/>
+          </a:xfrm>
+          <a:prstGeom prst="rect">
+            <a:avLst/>
+          </a:prstGeom>
+          <a:noFill/>
+        </p:spPr>
+        <p:txBody>
+          <a:bodyPr wrap="square">
+            <a:spAutoFit/>
+          </a:bodyPr>
+          <a:lstStyle/>
+          <a:p>
+            <a:r>
+              <a:rPr sz="1200" b="1">
+                <a:solidFill>
+                  <a:srgbClr val="5B6675"/>
+                </a:solidFill>
+                <a:latin typeface="Calibri"/>
+              </a:rPr>
+              <a:t>MERSCH75 · VEREINS-OS</a:t>
+            </a:r>
+          </a:p>
+        </p:txBody>
+      </p:sp>
+      <p:sp>
+        <p:nvSpPr>
+          <p:cNvPr id="4" name="TextBox 3"/>
+          <p:cNvSpPr txBox="1"/>
+          <p:nvPr/>
+        </p:nvSpPr>
+        <p:spPr>
+          <a:xfrm>
+            <a:off x="640080" y="731520"/>
+            <a:ext cx="10972800" cy="914400"/>
+          </a:xfrm>
+          <a:prstGeom prst="rect">
+            <a:avLst/>
+          </a:prstGeom>
+          <a:noFill/>
+        </p:spPr>
+        <p:txBody>
+          <a:bodyPr wrap="square">
+            <a:spAutoFit/>
+          </a:bodyPr>
+          <a:lstStyle/>
+          <a:p>
+            <a:r>
+              <a:rPr sz="3000" b="1">
+                <a:solidFill>
+                  <a:srgbClr val="002F65"/>
+                </a:solidFill>
+                <a:latin typeface="Calibri"/>
+              </a:rPr>
+              <a:t>Antrag an die Versammlung</a:t>
+            </a:r>
+          </a:p>
+        </p:txBody>
+      </p:sp>
+      <p:sp>
+        <p:nvSpPr>
+          <p:cNvPr id="5" name="TextBox 4"/>
+          <p:cNvSpPr txBox="1"/>
+          <p:nvPr/>
+        </p:nvSpPr>
+        <p:spPr>
+          <a:xfrm>
+            <a:off x="731520" y="1783080"/>
+            <a:ext cx="10789920" cy="4572000"/>
+          </a:xfrm>
+          <a:prstGeom prst="rect">
+            <a:avLst/>
+          </a:prstGeom>
+          <a:noFill/>
+        </p:spPr>
+        <p:txBody>
+          <a:bodyPr wrap="square">
+            <a:spAutoFit/>
+          </a:bodyPr>
+          <a:lstStyle/>
+          <a:p>
+            <a:pPr>
+              <a:spcAft>
+                <a:spcPts val="1000"/>
+              </a:spcAft>
+            </a:pPr>
+            <a:r>
+              <a:rPr sz="2000" b="1">
+                <a:solidFill>
+                  <a:srgbClr val="1C2530"/>
+                </a:solidFill>
+                <a:latin typeface="Calibri"/>
+              </a:rPr>
+              <a:t>•  Grundsatz: Verein setzt auf das eigene Vereins-OS.</a:t>
+            </a:r>
+          </a:p>
+          <a:p>
+            <a:pPr>
+              <a:spcAft>
+                <a:spcPts val="1000"/>
+              </a:spcAft>
+            </a:pPr>
+            <a:r>
+              <a:rPr sz="2000" b="1">
+                <a:solidFill>
+                  <a:srgbClr val="1C2530"/>
+                </a:solidFill>
+                <a:latin typeface="Calibri"/>
+              </a:rPr>
+              <a:t>•  Budgetfreigabe für Server-Hosting (kleiner Jahresbetrag).</a:t>
+            </a:r>
+          </a:p>
+          <a:p>
+            <a:pPr>
+              <a:spcAft>
+                <a:spcPts val="1000"/>
+              </a:spcAft>
+            </a:pPr>
+            <a:r>
+              <a:rPr sz="2000" b="1">
+                <a:solidFill>
+                  <a:srgbClr val="1C2530"/>
+                </a:solidFill>
+                <a:latin typeface="Calibri"/>
+              </a:rPr>
+              <a:t>•  Start Pilotbetrieb: „Mitglieder &amp; Beiträge".</a:t>
+            </a:r>
+          </a:p>
+          <a:p>
+            <a:pPr>
+              <a:spcAft>
+                <a:spcPts val="1000"/>
+              </a:spcAft>
+            </a:pPr>
+            <a:r>
+              <a:rPr sz="2000" b="1">
+                <a:solidFill>
+                  <a:srgbClr val="1C2530"/>
+                </a:solidFill>
+                <a:latin typeface="Calibri"/>
+              </a:rPr>
+              <a:t>•  Zweite Person zur Einarbeitung benennen (Ausfallsicherheit).</a:t>
+            </a:r>
+          </a:p>
+        </p:txBody>
+      </p:sp>
+    </p:spTree>
+  </p:cSld>
+  <p:clrMapOvr>
+    <a:masterClrMapping/>
+  </p:clrMapOvr>
+</p:sld>
+</file>
+
+<file path=ppt/slides/slide9.xml><?xml version="1.0" encoding="utf-8"?>
+<p:sld xmlns:a="http://schemas.openxmlformats.org/drawingml/2006/main" xmlns:p="http://schemas.openxmlformats.org/presentationml/2006/main" xmlns:r="http://schemas.openxmlformats.org/officeDocument/2006/relationships">
   <p:cSld>
     <p:bg>
       <p:bgPr>
@@ -4732,14 +4970,7 @@
         <p:cNvGrpSpPr/>
         <p:nvPr/>
       </p:nvGrpSpPr>
-      <p:grpSpPr>
-        <a:xfrm>
-          <a:off x="0" y="0"/>
-          <a:ext cx="0" cy="0"/>
-          <a:chOff x="0" y="0"/>
-          <a:chExt cx="0" cy="0"/>
-        </a:xfrm>
-      </p:grpSpPr>
+      <p:grpSpPr/>
       <p:sp>
         <p:nvSpPr>
           <p:cNvPr id="2" name="Rectangle 1"/>
@@ -4780,7 +5011,6 @@
           <a:lstStyle/>
           <a:p>
             <a:pPr algn="ctr"/>
-            <a:endParaRPr/>
           </a:p>
         </p:txBody>
       </p:sp>

</xml_diff>